<commit_message>
Rebuild: Session 1 on Sunday 1 November, Session 1 opening order, certificate rule
</commit_message>
<xml_diff>
--- a/en/files/slides/Session_8_EN.pptx
+++ b/en/files/slides/Session_8_EN.pptx
@@ -34879,7 +34879,7 @@
         </p:nvSpPr>
         <p:spPr>
           <a:xfrm>
-            <a:off x="457200" y="1958552"/>
+            <a:off x="457200" y="1849015"/>
             <a:ext cx="3625866" cy="640000"/>
           </a:xfrm>
           <a:prstGeom prst="rect">
@@ -34922,8 +34922,8 @@
         </p:nvSpPr>
         <p:spPr>
           <a:xfrm>
-            <a:off x="457200" y="2598552"/>
-            <a:ext cx="3625866" cy="1874342"/>
+            <a:off x="457200" y="2489015"/>
+            <a:ext cx="3625866" cy="2202954"/>
           </a:xfrm>
           <a:prstGeom prst="rect">
             <a:avLst/>
@@ -35003,77 +35003,6 @@
               <a:t>Results draft by 23:59, Sunday 20 December</a:t>
             </a:r>
           </a:p>
-        </p:txBody>
-      </p:sp>
-      <p:sp>
-        <p:nvSpPr>
-          <p:cNvPr id="72" name="CardHead"/>
-          <p:cNvSpPr/>
-          <p:nvPr/>
-        </p:nvSpPr>
-        <p:spPr>
-          <a:xfrm>
-            <a:off x="4283066" y="1958552"/>
-            <a:ext cx="3625866" cy="640000"/>
-          </a:xfrm>
-          <a:prstGeom prst="rect">
-            <a:avLst/>
-          </a:prstGeom>
-          <a:solidFill>
-            <a:srgbClr val="0B376C"/>
-          </a:solidFill>
-          <a:ln>
-            <a:noFill/>
-          </a:ln>
-        </p:spPr>
-        <p:txBody>
-          <a:bodyPr wrap="square" lIns="91440" tIns="45720" rIns="91440" bIns="45720" rtlCol="0" anchor="ctr">
-            <a:normAutofit/>
-          </a:bodyPr>
-          <a:lstStyle/>
-          <a:p>
-            <a:pPr marL="0" indent="0" algn="ctr">
-              <a:buNone/>
-            </a:pPr>
-            <a:r>
-              <a:rPr lang="en-US" sz="1900" b="1" dirty="0">
-                <a:solidFill>
-                  <a:srgbClr val="FFFFFF"/>
-                </a:solidFill>
-                <a:latin typeface="Arial"/>
-                <a:cs typeface="Arial"/>
-              </a:rPr>
-              <a:t>Your toolkit</a:t>
-            </a:r>
-          </a:p>
-        </p:txBody>
-      </p:sp>
-      <p:sp>
-        <p:nvSpPr>
-          <p:cNvPr id="73" name="CardBody"/>
-          <p:cNvSpPr/>
-          <p:nvPr/>
-        </p:nvSpPr>
-        <p:spPr>
-          <a:xfrm>
-            <a:off x="4283066" y="2598552"/>
-            <a:ext cx="3625866" cy="1874342"/>
-          </a:xfrm>
-          <a:prstGeom prst="rect">
-            <a:avLst/>
-          </a:prstGeom>
-          <a:solidFill>
-            <a:srgbClr val="EAF2F5"/>
-          </a:solidFill>
-          <a:ln>
-            <a:noFill/>
-          </a:ln>
-        </p:spPr>
-        <p:txBody>
-          <a:bodyPr wrap="square" lIns="137160" tIns="91440" rIns="137160" bIns="91440" rtlCol="0" anchor="ctr">
-            <a:normAutofit/>
-          </a:bodyPr>
-          <a:lstStyle/>
           <a:p>
             <a:pPr marL="0" indent="0" algn="ctr">
               <a:lnSpc>
@@ -35092,9 +35021,80 @@
                 <a:latin typeface="Arial"/>
                 <a:cs typeface="Arial"/>
               </a:rPr>
-              <a:t>Slides, handouts, glossary</a:t>
-            </a:r>
-          </a:p>
+              <a:t>Review by 30 December, revision by 9 January</a:t>
+            </a:r>
+          </a:p>
+        </p:txBody>
+      </p:sp>
+      <p:sp>
+        <p:nvSpPr>
+          <p:cNvPr id="72" name="CardHead"/>
+          <p:cNvSpPr/>
+          <p:nvPr/>
+        </p:nvSpPr>
+        <p:spPr>
+          <a:xfrm>
+            <a:off x="4283066" y="1849015"/>
+            <a:ext cx="3625866" cy="640000"/>
+          </a:xfrm>
+          <a:prstGeom prst="rect">
+            <a:avLst/>
+          </a:prstGeom>
+          <a:solidFill>
+            <a:srgbClr val="0B376C"/>
+          </a:solidFill>
+          <a:ln>
+            <a:noFill/>
+          </a:ln>
+        </p:spPr>
+        <p:txBody>
+          <a:bodyPr wrap="square" lIns="91440" tIns="45720" rIns="91440" bIns="45720" rtlCol="0" anchor="ctr">
+            <a:normAutofit/>
+          </a:bodyPr>
+          <a:lstStyle/>
+          <a:p>
+            <a:pPr marL="0" indent="0" algn="ctr">
+              <a:buNone/>
+            </a:pPr>
+            <a:r>
+              <a:rPr lang="en-US" sz="1900" b="1" dirty="0">
+                <a:solidFill>
+                  <a:srgbClr val="FFFFFF"/>
+                </a:solidFill>
+                <a:latin typeface="Arial"/>
+                <a:cs typeface="Arial"/>
+              </a:rPr>
+              <a:t>Your toolkit</a:t>
+            </a:r>
+          </a:p>
+        </p:txBody>
+      </p:sp>
+      <p:sp>
+        <p:nvSpPr>
+          <p:cNvPr id="73" name="CardBody"/>
+          <p:cNvSpPr/>
+          <p:nvPr/>
+        </p:nvSpPr>
+        <p:spPr>
+          <a:xfrm>
+            <a:off x="4283066" y="2489015"/>
+            <a:ext cx="3625866" cy="2202954"/>
+          </a:xfrm>
+          <a:prstGeom prst="rect">
+            <a:avLst/>
+          </a:prstGeom>
+          <a:solidFill>
+            <a:srgbClr val="EAF2F5"/>
+          </a:solidFill>
+          <a:ln>
+            <a:noFill/>
+          </a:ln>
+        </p:spPr>
+        <p:txBody>
+          <a:bodyPr wrap="square" lIns="137160" tIns="91440" rIns="137160" bIns="91440" rtlCol="0" anchor="ctr">
+            <a:normAutofit/>
+          </a:bodyPr>
+          <a:lstStyle/>
           <a:p>
             <a:pPr marL="0" indent="0" algn="ctr">
               <a:lnSpc>
@@ -35113,6 +35113,27 @@
                 <a:latin typeface="Arial"/>
                 <a:cs typeface="Arial"/>
               </a:rPr>
+              <a:t>Slides, handouts, glossary</a:t>
+            </a:r>
+          </a:p>
+          <a:p>
+            <a:pPr marL="0" indent="0" algn="ctr">
+              <a:lnSpc>
+                <a:spcPct val="104000"/>
+              </a:lnSpc>
+              <a:spcBef>
+                <a:spcPts val="400"/>
+              </a:spcBef>
+              <a:buNone/>
+            </a:pPr>
+            <a:r>
+              <a:rPr lang="en-US" sz="1750" dirty="0">
+                <a:solidFill>
+                  <a:srgbClr val="000000"/>
+                </a:solidFill>
+                <a:latin typeface="Arial"/>
+                <a:cs typeface="Arial"/>
+              </a:rPr>
               <a:t>Templates for every step, from proposal to response to reviewers</a:t>
             </a:r>
           </a:p>
@@ -35126,7 +35147,7 @@
         </p:nvSpPr>
         <p:spPr>
           <a:xfrm>
-            <a:off x="8108932" y="1958552"/>
+            <a:off x="8108932" y="1849015"/>
             <a:ext cx="3625866" cy="640000"/>
           </a:xfrm>
           <a:prstGeom prst="rect">
@@ -35169,8 +35190,8 @@
         </p:nvSpPr>
         <p:spPr>
           <a:xfrm>
-            <a:off x="8108932" y="2598552"/>
-            <a:ext cx="3625866" cy="1874342"/>
+            <a:off x="8108932" y="2489015"/>
+            <a:ext cx="3625866" cy="2202954"/>
           </a:xfrm>
           <a:prstGeom prst="rect">
             <a:avLst/>

</xml_diff>